<commit_message>
Update rendered pptx from publish render
Co-Authored-By: Claude Opus 5 <noreply@anthropic.com>
Claude-Session: https://claude.ai/code/session_01KGQgHj3Y3cX8DbDTJrr99H
</commit_message>
<xml_diff>
--- a/slides-v2.pptx
+++ b/slides-v2.pptx
@@ -10354,27 +10354,36 @@
           </a:p>
         </p:txBody>
       </p:sp>
-      <p:sp>
-        <p:nvSpPr>
-          <p:cNvPr id="3" name="Content Placeholder 2"/>
-          <p:cNvSpPr>
-            <a:spLocks noGrp="1"/>
-          </p:cNvSpPr>
-          <p:nvPr>
-            <p:ph idx="1"/>
-          </p:nvPr>
-        </p:nvSpPr>
-        <p:spPr/>
-        <p:txBody>
-          <a:bodyPr/>
-          <a:lstStyle/>
-          <a:p>
-            <a:pPr lvl="0" indent="0" marL="0">
-              <a:buNone/>
-            </a:pPr>
-          </a:p>
-        </p:txBody>
-      </p:sp>
+      <p:pic>
+        <p:nvPicPr>
+          <p:cNvPr descr="assets/notability-v2/transparent-helper-left.png" id="0" name="Picture 1"/>
+          <p:cNvPicPr>
+            <a:picLocks noGrp="1" noChangeAspect="1"/>
+          </p:cNvPicPr>
+          <p:nvPr/>
+        </p:nvPicPr>
+        <p:blipFill>
+          <a:blip r:embed="rId2"/>
+          <a:stretch>
+            <a:fillRect/>
+          </a:stretch>
+        </p:blipFill>
+        <p:spPr bwMode="auto">
+          <a:xfrm>
+            <a:off x="2184400" y="1193800"/>
+            <a:ext cx="4775200" cy="3390900"/>
+          </a:xfrm>
+          <a:prstGeom prst="rect">
+            <a:avLst/>
+          </a:prstGeom>
+          <a:noFill/>
+          <a:ln w="9525">
+            <a:noFill/>
+            <a:headEnd/>
+            <a:tailEnd/>
+          </a:ln>
+        </p:spPr>
+      </p:pic>
     </p:spTree>
   </p:cSld>
 </p:sld>
@@ -13395,27 +13404,36 @@
           </a:p>
         </p:txBody>
       </p:sp>
-      <p:sp>
-        <p:nvSpPr>
-          <p:cNvPr id="3" name="Content Placeholder 2"/>
-          <p:cNvSpPr>
-            <a:spLocks noGrp="1"/>
-          </p:cNvSpPr>
-          <p:nvPr>
-            <p:ph idx="1"/>
-          </p:nvPr>
-        </p:nvSpPr>
-        <p:spPr/>
-        <p:txBody>
-          <a:bodyPr/>
-          <a:lstStyle/>
-          <a:p>
-            <a:pPr lvl="0" indent="0" marL="0">
-              <a:buNone/>
-            </a:pPr>
-          </a:p>
-        </p:txBody>
-      </p:sp>
+      <p:pic>
+        <p:nvPicPr>
+          <p:cNvPr descr="assets/notability-v2/code-to-helper-01.png" id="0" name="Picture 1"/>
+          <p:cNvPicPr>
+            <a:picLocks noGrp="1" noChangeAspect="1"/>
+          </p:cNvPicPr>
+          <p:nvPr/>
+        </p:nvPicPr>
+        <p:blipFill>
+          <a:blip r:embed="rId2"/>
+          <a:stretch>
+            <a:fillRect/>
+          </a:stretch>
+        </p:blipFill>
+        <p:spPr bwMode="auto">
+          <a:xfrm>
+            <a:off x="2184400" y="1193800"/>
+            <a:ext cx="4775200" cy="3390900"/>
+          </a:xfrm>
+          <a:prstGeom prst="rect">
+            <a:avLst/>
+          </a:prstGeom>
+          <a:noFill/>
+          <a:ln w="9525">
+            <a:noFill/>
+            <a:headEnd/>
+            <a:tailEnd/>
+          </a:ln>
+        </p:spPr>
+      </p:pic>
     </p:spTree>
   </p:cSld>
 </p:sld>
@@ -13463,27 +13481,36 @@
           </a:p>
         </p:txBody>
       </p:sp>
-      <p:sp>
-        <p:nvSpPr>
-          <p:cNvPr id="3" name="Content Placeholder 2"/>
-          <p:cNvSpPr>
-            <a:spLocks noGrp="1"/>
-          </p:cNvSpPr>
-          <p:nvPr>
-            <p:ph idx="1"/>
-          </p:nvPr>
-        </p:nvSpPr>
-        <p:spPr/>
-        <p:txBody>
-          <a:bodyPr/>
-          <a:lstStyle/>
-          <a:p>
-            <a:pPr lvl="0" indent="0" marL="0">
-              <a:buNone/>
-            </a:pPr>
-          </a:p>
-        </p:txBody>
-      </p:sp>
+      <p:pic>
+        <p:nvPicPr>
+          <p:cNvPr descr="assets/notability-v2/code-to-helper-03.png" id="0" name="Picture 1"/>
+          <p:cNvPicPr>
+            <a:picLocks noGrp="1" noChangeAspect="1"/>
+          </p:cNvPicPr>
+          <p:nvPr/>
+        </p:nvPicPr>
+        <p:blipFill>
+          <a:blip r:embed="rId2"/>
+          <a:stretch>
+            <a:fillRect/>
+          </a:stretch>
+        </p:blipFill>
+        <p:spPr bwMode="auto">
+          <a:xfrm>
+            <a:off x="2184400" y="1193800"/>
+            <a:ext cx="4775200" cy="3390900"/>
+          </a:xfrm>
+          <a:prstGeom prst="rect">
+            <a:avLst/>
+          </a:prstGeom>
+          <a:noFill/>
+          <a:ln w="9525">
+            <a:noFill/>
+            <a:headEnd/>
+            <a:tailEnd/>
+          </a:ln>
+        </p:spPr>
+      </p:pic>
     </p:spTree>
   </p:cSld>
 </p:sld>
@@ -13531,27 +13558,36 @@
           </a:p>
         </p:txBody>
       </p:sp>
-      <p:sp>
-        <p:nvSpPr>
-          <p:cNvPr id="3" name="Content Placeholder 2"/>
-          <p:cNvSpPr>
-            <a:spLocks noGrp="1"/>
-          </p:cNvSpPr>
-          <p:nvPr>
-            <p:ph idx="1"/>
-          </p:nvPr>
-        </p:nvSpPr>
-        <p:spPr/>
-        <p:txBody>
-          <a:bodyPr/>
-          <a:lstStyle/>
-          <a:p>
-            <a:pPr lvl="0" indent="0" marL="0">
-              <a:buNone/>
-            </a:pPr>
-          </a:p>
-        </p:txBody>
-      </p:sp>
+      <p:pic>
+        <p:nvPicPr>
+          <p:cNvPr descr="assets/temp/fig-ggtime-teaser.png" id="0" name="Picture 1"/>
+          <p:cNvPicPr>
+            <a:picLocks noGrp="1" noChangeAspect="1"/>
+          </p:cNvPicPr>
+          <p:nvPr/>
+        </p:nvPicPr>
+        <p:blipFill>
+          <a:blip r:embed="rId2"/>
+          <a:stretch>
+            <a:fillRect/>
+          </a:stretch>
+        </p:blipFill>
+        <p:spPr bwMode="auto">
+          <a:xfrm>
+            <a:off x="457200" y="1485900"/>
+            <a:ext cx="8229600" cy="2806700"/>
+          </a:xfrm>
+          <a:prstGeom prst="rect">
+            <a:avLst/>
+          </a:prstGeom>
+          <a:noFill/>
+          <a:ln w="9525">
+            <a:noFill/>
+            <a:headEnd/>
+            <a:tailEnd/>
+          </a:ln>
+        </p:spPr>
+      </p:pic>
     </p:spTree>
   </p:cSld>
 </p:sld>
@@ -13594,32 +13630,41 @@
             </a:pPr>
             <a:r>
               <a:rPr/>
-              <a:t>Stay calm, and…</a:t>
+              <a:t>Keep calm, and…</a:t>
             </a:r>
           </a:p>
         </p:txBody>
       </p:sp>
-      <p:sp>
-        <p:nvSpPr>
-          <p:cNvPr id="3" name="Content Placeholder 2"/>
-          <p:cNvSpPr>
-            <a:spLocks noGrp="1"/>
-          </p:cNvSpPr>
-          <p:nvPr>
-            <p:ph idx="1"/>
-          </p:nvPr>
-        </p:nvSpPr>
-        <p:spPr/>
-        <p:txBody>
-          <a:bodyPr/>
-          <a:lstStyle/>
-          <a:p>
-            <a:pPr lvl="0" indent="0" marL="0">
-              <a:buNone/>
-            </a:pPr>
-          </a:p>
-        </p:txBody>
-      </p:sp>
+      <p:pic>
+        <p:nvPicPr>
+          <p:cNvPr descr="assets/notability-v2/principle-summary-v2-with-text.jpg" id="0" name="Picture 1"/>
+          <p:cNvPicPr>
+            <a:picLocks noGrp="1" noChangeAspect="1"/>
+          </p:cNvPicPr>
+          <p:nvPr/>
+        </p:nvPicPr>
+        <p:blipFill>
+          <a:blip r:embed="rId2"/>
+          <a:stretch>
+            <a:fillRect/>
+          </a:stretch>
+        </p:blipFill>
+        <p:spPr bwMode="auto">
+          <a:xfrm>
+            <a:off x="2184400" y="1193800"/>
+            <a:ext cx="4775200" cy="3390900"/>
+          </a:xfrm>
+          <a:prstGeom prst="rect">
+            <a:avLst/>
+          </a:prstGeom>
+          <a:noFill/>
+          <a:ln w="9525">
+            <a:noFill/>
+            <a:headEnd/>
+            <a:tailEnd/>
+          </a:ln>
+        </p:spPr>
+      </p:pic>
     </p:spTree>
   </p:cSld>
 </p:sld>
@@ -13967,7 +14012,7 @@
       </p:sp>
       <p:pic>
         <p:nvPicPr>
-          <p:cNvPr descr="assets/code-blocks/ggweekly-README-year-week-1.png" id="0" name="Picture 1"/>
+          <p:cNvPr descr="assets/code-blocks/ggweekly-README-year-week-1-cropped.png" id="0" name="Picture 1"/>
           <p:cNvPicPr>
             <a:picLocks noGrp="1" noChangeAspect="1"/>
           </p:cNvPicPr>
@@ -13981,8 +14026,8 @@
         </p:blipFill>
         <p:spPr bwMode="auto">
           <a:xfrm>
-            <a:off x="4800600" y="1625600"/>
-            <a:ext cx="3695700" cy="2959100"/>
+            <a:off x="4635500" y="1968500"/>
+            <a:ext cx="4038600" cy="2273300"/>
           </a:xfrm>
           <a:prstGeom prst="rect">
             <a:avLst/>

</xml_diff>

<commit_message>
Add gh-pages publish record and rewrite README for posit::conf(2026)
- Record the gh-pages target in _publish.yml so `quarto publish gh-pages`
  can be run interactively without re-initialising the remote
- Rewrite README.md for posit::conf(2026): new title, slides link, repo
  guide and build/publish instructions; keep a pointer to the earlier
  MelbURN/SSA version of the talk
- Drop the .sketch-container wrapper around the ggtilecal crop, and
  re-render the html/pptx outputs

Co-Authored-By: Claude Opus 5 <noreply@anthropic.com>
Claude-Session: https://claude.ai/code/session_01KGQgHj3Y3cX8DbDTJrr99H
</commit_message>
<xml_diff>
--- a/slides-v2.pptx
+++ b/slides-v2.pptx
@@ -4020,27 +4020,36 @@
           <a:chExt cx="0" cy="0"/>
         </a:xfrm>
       </p:grpSpPr>
-      <p:sp>
-        <p:nvSpPr>
-          <p:cNvPr id="3" name="Content Placeholder 2"/>
-          <p:cNvSpPr>
-            <a:spLocks noGrp="1"/>
-          </p:cNvSpPr>
-          <p:nvPr>
-            <p:ph idx="1" sz="half"/>
-          </p:nvPr>
-        </p:nvSpPr>
-        <p:spPr/>
-        <p:txBody>
-          <a:bodyPr/>
-          <a:lstStyle/>
-          <a:p>
-            <a:pPr lvl="0" indent="0" marL="0">
-              <a:buNone/>
-            </a:pPr>
-          </a:p>
-        </p:txBody>
-      </p:sp>
+      <p:pic>
+        <p:nvPicPr>
+          <p:cNvPr descr="assets/temp/ggtilecal-crop.png" id="0" name="Picture 1"/>
+          <p:cNvPicPr>
+            <a:picLocks noGrp="1" noChangeAspect="1"/>
+          </p:cNvPicPr>
+          <p:nvPr/>
+        </p:nvPicPr>
+        <p:blipFill>
+          <a:blip r:embed="rId2"/>
+          <a:stretch>
+            <a:fillRect/>
+          </a:stretch>
+        </p:blipFill>
+        <p:spPr bwMode="auto">
+          <a:xfrm>
+            <a:off x="914400" y="1193800"/>
+            <a:ext cx="3124200" cy="3390900"/>
+          </a:xfrm>
+          <a:prstGeom prst="rect">
+            <a:avLst/>
+          </a:prstGeom>
+          <a:noFill/>
+          <a:ln w="9525">
+            <a:noFill/>
+            <a:headEnd/>
+            <a:tailEnd/>
+          </a:ln>
+        </p:spPr>
+      </p:pic>
       <p:sp>
         <p:nvSpPr>
           <p:cNvPr id="4" name="Content Placeholder 3"/>

</xml_diff>